<commit_message>
Burn script, DepositAndMint script, and Liquidate script added
</commit_message>
<xml_diff>
--- a/docs/Avalanche_Stabletoken_Workshop_Presentation.pptx
+++ b/docs/Avalanche_Stabletoken_Workshop_Presentation.pptx
@@ -3588,7 +3588,7 @@
               <a:t>Our SBT </a:t>
             </a:r>
             <a:r>
-              <a:rPr lang="en-US" sz="1150">
+              <a:rPr lang="en-US" sz="1150" dirty="0" err="1">
                 <a:solidFill>
                   <a:srgbClr val="A0A0B0"/>
                 </a:solidFill>
@@ -3596,7 +3596,7 @@
                 <a:ea typeface="Calibri" pitchFamily="34" charset="-122"/>
                 <a:cs typeface="Calibri" pitchFamily="34" charset="-120"/>
               </a:rPr>
-              <a:t>stabletoken </a:t>
+              <a:t>stabletoken</a:t>
             </a:r>
             <a:r>
               <a:rPr lang="en-US" sz="1150" dirty="0">
@@ -3607,7 +3607,7 @@
                 <a:ea typeface="Calibri" pitchFamily="34" charset="-122"/>
                 <a:cs typeface="Calibri" pitchFamily="34" charset="-120"/>
               </a:rPr>
-              <a:t>is deployed on the Avalanche Fuji - C-Chain </a:t>
+              <a:t> is deployed on the Avalanche Fuji - C-Chain </a:t>
             </a:r>
             <a:r>
               <a:rPr lang="en-US" sz="1150" dirty="0" err="1">

</xml_diff>